<commit_message>
EN: H1, H2, H4, H5, H6 notları ve ilk İngilizce deste; derleyiciye EN sunum desteği
Çeviriler (TR -> EN satır): H1 2677->2757 · H2 2456->2578 · H4 2276->2350
· H5 1968->2042 · H6 1814->1847. Her birinde başlık, görsel, kod bloğu,
soru, kutu ve sekmeli blok sayıları Türkçesiyle birebir; görsel yolları
değişmedi, iç bağlantı çapaları İngilizce başlıklara göre yeniden
üretilip çözüldükleri doğrulandı.

**Derleyici eksiği giderildi:** build_outputs.py İngilizce sunum
kaynağını hiç desteklemiyordu; Türkçe HTML'i kopyalayıp İngilizce adıyla
kaydediyordu. Artık `slides/week-N/cen429-week-N.en.md` varsa sunum HTML,
PDF ve PPTX o kaynaktan üretiliyor; yoksa eski davranış (kopyalama)
sürüyor. İlk İngilizce deste (H16, 31 slayt) bu yolla derlenip doğrulandı.

Ayrıca H2'de iki yanlış çapraz atıf düzeltildi: olmayan "Demo 16" ->
"Demo 05" (iki yer) ve "bölüm 8 ile birlikte" -> "bölüm 11 ile birlikte".
Görsellerin çevresine eksik kalan boş satırlar 8 dosyada tamamlandı.
</commit_message>
<xml_diff>
--- a/docs/week-16/cen429-week-16-sunum.en.pptx
+++ b/docs/week-16/cen429-week-16-sunum.en.pptx
@@ -532,7 +532,7 @@
           <a:lstStyle/>
           <a:p>
             <a:r>
-              <a:t>Quiz-2 dönemi: 9-14. haftaların kavramlarını tekrar ediyoruz; bu sunum çalışma rehberidir.</a:t>
+              <a:t>Speaker note: Quiz-2 period: we review the concepts of weeks 9-14; this deck is a study guide.</a:t>
             </a:r>
           </a:p>
         </p:txBody>
@@ -602,7 +602,7 @@
           <a:lstStyle/>
           <a:p>
             <a:r>
-              <a:t>1) ~112 bit; RSA-3072 ya da X25519. 2) Dolgu kâhini; tek hata, AEAD. 3) Negatif hata geçerli sayılır; == 1 ve sürüm imzalı olmalı. 4) Zincir köke ulaşmıyor. 5) Fail-open; Must-Staple, kısa ömür. 6) İmzalı DH, CertificateVerify.</a:t>
+              <a:t>Speaker note: 1) ~112 bits; RSA-3072 or X25519. 2) Padding oracle; single error, AEAD. 3) A negative error counts as valid; must be == 1, and the version must be signed. 4) The chain doesn't reach the root. 5) Fail-open; Must-Staple, short lifetime. 6) Signed DH, CertificateVerify.</a:t>
             </a:r>
           </a:p>
         </p:txBody>
@@ -672,7 +672,7 @@
           <a:lstStyle/>
           <a:p>
             <a:r>
-              <a:t>Cevaplar 16. hafta sayfasında açılır kutularda.</a:t>
+              <a:t>Speaker note: Answers appear in collapsible boxes on the Week 16 page.</a:t>
             </a:r>
           </a:p>
         </p:txBody>
@@ -742,7 +742,7 @@
           <a:lstStyle/>
           <a:p>
             <a:r>
-              <a:t>Quiz-2 kapsamı 9-14. hafta. Artık 9, 11, 14. haftalar yayımlandı; örnek soruları eklendi.</a:t>
+              <a:t>Speaker note: Quiz-2 covers weeks 9-14. Weeks 9, 11, and 14 have now been published; sample questions have been added.</a:t>
             </a:r>
           </a:p>
         </p:txBody>
@@ -3800,7 +3800,7 @@
                   <a:srgbClr val="5B6770"/>
                 </a:solidFill>
               </a:rPr>
-              <a:t>CEN429 Güvenli Programlama · Hafta 16</a:t>
+              <a:t>CEN429 Secure Programming · Week 16</a:t>
             </a:r>
           </a:p>
         </p:txBody>
@@ -3833,7 +3833,7 @@
                   <a:srgbClr val="5B6770"/>
                 </a:solidFill>
               </a:rPr>
-              <a:t>RTEÜ Bilgisayar Mühendisliği · 2026-2027 Güz</a:t>
+              <a:t>RTEU Computer Engineering · 2026-2027 Fall</a:t>
             </a:r>
           </a:p>
         </p:txBody>
@@ -3867,7 +3867,7 @@
                   <a:srgbClr val="006D77"/>
                 </a:solidFill>
               </a:rPr>
-              <a:t>Final Dönemi: Quiz-2</a:t>
+              <a:t>Final Exam Period: Quiz-2</a:t>
             </a:r>
           </a:p>
         </p:txBody>
@@ -3901,7 +3901,7 @@
                   <a:srgbClr val="1F2D3A"/>
                 </a:solidFill>
               </a:rPr>
-              <a:t>CEN429 Güvenli Programlama — Hafta 16</a:t>
+              <a:t>CEN429 Secure Programming — Week 16</a:t>
             </a:r>
           </a:p>
         </p:txBody>
@@ -3935,7 +3935,7 @@
                   <a:srgbClr val="1F2D3A"/>
                 </a:solidFill>
               </a:rPr>
-              <a:t>Dr. Öğr. Üyesi Uğur CORUH · 04–17.01.2027</a:t>
+              <a:t>Asst. Prof. Dr. Uğur CORUH · 04–17.01.2027</a:t>
             </a:r>
           </a:p>
         </p:txBody>
@@ -4010,7 +4010,7 @@
                   <a:srgbClr val="5B6770"/>
                 </a:solidFill>
               </a:rPr>
-              <a:t>CEN429 Güvenli Programlama · Hafta 16</a:t>
+              <a:t>CEN429 Secure Programming · Week 16</a:t>
             </a:r>
           </a:p>
         </p:txBody>
@@ -4043,7 +4043,7 @@
                   <a:srgbClr val="5B6770"/>
                 </a:solidFill>
               </a:rPr>
-              <a:t>RTEÜ Bilgisayar Mühendisliği · 2026-2027 Güz</a:t>
+              <a:t>RTEU Computer Engineering · 2026-2027 Fall</a:t>
             </a:r>
           </a:p>
         </p:txBody>
@@ -4110,7 +4110,7 @@
                   <a:srgbClr val="006D77"/>
                 </a:solidFill>
               </a:rPr>
-              <a:t>İyi şanslar</a:t>
+              <a:t>Good Luck</a:t>
             </a:r>
           </a:p>
         </p:txBody>
@@ -4124,7 +4124,7 @@
         <p:spPr>
           <a:xfrm>
             <a:off x="640080" y="1325880"/>
-            <a:ext cx="10911535" cy="843280"/>
+            <a:ext cx="10911535" cy="1173480"/>
           </a:xfrm>
           <a:prstGeom prst="rect">
             <a:avLst/>
@@ -4156,7 +4156,7 @@
                   <a:srgbClr val="1F2D3A"/>
                 </a:solidFill>
               </a:rPr>
-              <a:t>Cevapları 16. hafta sayfasında</a:t>
+              <a:t>Answers on the Week 16 page</a:t>
             </a:r>
           </a:p>
           <a:p>
@@ -4179,7 +4179,7 @@
                   <a:srgbClr val="1F2D3A"/>
                 </a:solidFill>
               </a:rPr>
-              <a:t>Kılavuzunuz bir </a:t>
+              <a:t>Your guide is a </a:t>
             </a:r>
             <a:r>
               <a:rPr sz="2000" b="1">
@@ -4187,7 +4187,7 @@
                   <a:srgbClr val="1F2D3A"/>
                 </a:solidFill>
               </a:rPr>
-              <a:t>portfolyo</a:t>
+              <a:t>portfolio</a:t>
             </a:r>
             <a:r>
               <a:rPr sz="2000" b="0">
@@ -4195,7 +4195,7 @@
                   <a:srgbClr val="1F2D3A"/>
                 </a:solidFill>
               </a:rPr>
-              <a:t> öğesidir (gizli bilgi içermediğinden emin olun)</a:t>
+              <a:t> item (make sure it contains no confidential information)</a:t>
             </a:r>
           </a:p>
         </p:txBody>
@@ -4270,7 +4270,7 @@
                   <a:srgbClr val="5B6770"/>
                 </a:solidFill>
               </a:rPr>
-              <a:t>CEN429 Güvenli Programlama · Hafta 16</a:t>
+              <a:t>CEN429 Secure Programming · Week 16</a:t>
             </a:r>
           </a:p>
         </p:txBody>
@@ -4303,7 +4303,7 @@
                   <a:srgbClr val="5B6770"/>
                 </a:solidFill>
               </a:rPr>
-              <a:t>RTEÜ Bilgisayar Mühendisliği · 2026-2027 Güz</a:t>
+              <a:t>RTEU Computer Engineering · 2026-2027 Fall</a:t>
             </a:r>
           </a:p>
         </p:txBody>
@@ -4370,7 +4370,7 @@
                   <a:srgbClr val="006D77"/>
                 </a:solidFill>
               </a:rPr>
-              <a:t>Dönemin tek cümlesi — şema</a:t>
+              <a:t>The Term in One Sentence — Diagram</a:t>
             </a:r>
           </a:p>
         </p:txBody>
@@ -4453,7 +4453,7 @@
                   <a:srgbClr val="D8F0F2"/>
                 </a:solidFill>
               </a:rPr>
-              <a:t>CEN429 Güvenli Programlama · Hafta 16</a:t>
+              <a:t>CEN429 Secure Programming · Week 16</a:t>
             </a:r>
           </a:p>
         </p:txBody>
@@ -4486,7 +4486,7 @@
                   <a:srgbClr val="D8F0F2"/>
                 </a:solidFill>
               </a:rPr>
-              <a:t>RTEÜ Bilgisayar Mühendisliği · 2026-2027 Güz</a:t>
+              <a:t>RTEU Computer Engineering · 2026-2027 Fall</a:t>
             </a:r>
           </a:p>
         </p:txBody>
@@ -4554,7 +4554,7 @@
                   <a:srgbClr val="FFFFFF"/>
                 </a:solidFill>
               </a:rPr>
-              <a:t>Ek · Hafta hafta konu haritası (9–14)</a:t>
+              <a:t>Appendix · Week-by-Week Topic Map (9–14)</a:t>
             </a:r>
           </a:p>
         </p:txBody>
@@ -4629,7 +4629,7 @@
                   <a:srgbClr val="5B6770"/>
                 </a:solidFill>
               </a:rPr>
-              <a:t>CEN429 Güvenli Programlama · Hafta 16</a:t>
+              <a:t>CEN429 Secure Programming · Week 16</a:t>
             </a:r>
           </a:p>
         </p:txBody>
@@ -4662,7 +4662,7 @@
                   <a:srgbClr val="5B6770"/>
                 </a:solidFill>
               </a:rPr>
-              <a:t>RTEÜ Bilgisayar Mühendisliği · 2026-2027 Güz</a:t>
+              <a:t>RTEU Computer Engineering · 2026-2027 Fall</a:t>
             </a:r>
           </a:p>
         </p:txBody>
@@ -4729,7 +4729,7 @@
                   <a:srgbClr val="006D77"/>
                 </a:solidFill>
               </a:rPr>
-              <a:t>9. hafta · anahtar noktalar</a:t>
+              <a:t>Week 9 · Key Points</a:t>
             </a:r>
           </a:p>
         </p:txBody>
@@ -4743,7 +4743,7 @@
         <p:spPr>
           <a:xfrm>
             <a:off x="640080" y="1325880"/>
-            <a:ext cx="10911535" cy="1595120"/>
+            <a:ext cx="10911535" cy="1925320"/>
           </a:xfrm>
           <a:prstGeom prst="rect">
             <a:avLst/>
@@ -4775,7 +4775,7 @@
                   <a:srgbClr val="1F2D3A"/>
                 </a:solidFill>
               </a:rPr>
-              <a:t>Gizleme: kırılamazlık değil </a:t>
+              <a:t>Obfuscation: not unbreakability, but </a:t>
             </a:r>
             <a:r>
               <a:rPr sz="2000" b="1">
@@ -4783,7 +4783,7 @@
                   <a:srgbClr val="1F2D3A"/>
                 </a:solidFill>
               </a:rPr>
-              <a:t>maliyet</a:t>
+              <a:t>cost</a:t>
             </a:r>
             <a:r>
               <a:rPr sz="2000" b="0">
@@ -4814,7 +4814,7 @@
                   <a:srgbClr val="1F2D3A"/>
                 </a:solidFill>
               </a:rPr>
-              <a:t>Kurallar: opak yüklem, düzleştirme, sahte/ölü, veri kodlama.</a:t>
+              <a:t>Techniques: opaque predicates, control-flow flattening, bogus/dead code, data encoding.</a:t>
             </a:r>
           </a:p>
           <a:p>
@@ -4837,7 +4837,7 @@
                   <a:srgbClr val="1F2D3A"/>
                 </a:solidFill>
               </a:rPr>
-              <a:t>Ölçme: güç, dayanıklılık, gizlilik, maliyet.</a:t>
+              <a:t>Measurement: potency, resilience, stealth, cost.</a:t>
             </a:r>
           </a:p>
           <a:p>
@@ -4860,7 +4860,7 @@
                   <a:srgbClr val="1F2D3A"/>
                 </a:solidFill>
               </a:rPr>
-              <a:t>Çeşitlendirme.</a:t>
+              <a:t>Diversification.</a:t>
             </a:r>
           </a:p>
         </p:txBody>
@@ -4935,7 +4935,7 @@
                   <a:srgbClr val="5B6770"/>
                 </a:solidFill>
               </a:rPr>
-              <a:t>CEN429 Güvenli Programlama · Hafta 16</a:t>
+              <a:t>CEN429 Secure Programming · Week 16</a:t>
             </a:r>
           </a:p>
         </p:txBody>
@@ -4968,7 +4968,7 @@
                   <a:srgbClr val="5B6770"/>
                 </a:solidFill>
               </a:rPr>
-              <a:t>RTEÜ Bilgisayar Mühendisliği · 2026-2027 Güz</a:t>
+              <a:t>RTEU Computer Engineering · 2026-2027 Fall</a:t>
             </a:r>
           </a:p>
         </p:txBody>
@@ -5035,7 +5035,7 @@
                   <a:srgbClr val="006D77"/>
                 </a:solidFill>
               </a:rPr>
-              <a:t>10. hafta · anahtar noktalar</a:t>
+              <a:t>Week 10 · Key Points</a:t>
             </a:r>
           </a:p>
         </p:txBody>
@@ -5081,7 +5081,7 @@
                   <a:srgbClr val="1F2D3A"/>
                 </a:solidFill>
               </a:rPr>
-              <a:t>Güvenlik düzeyi; en zayıf halka.</a:t>
+              <a:t>Security level; weakest link.</a:t>
             </a:r>
           </a:p>
           <a:p>
@@ -5104,7 +5104,7 @@
                   <a:srgbClr val="1F2D3A"/>
                 </a:solidFill>
               </a:rPr>
-              <a:t>Kip ve dolgu; dolgu kâhini → AEAD.</a:t>
+              <a:t>Modes and padding; padding oracle → AEAD.</a:t>
             </a:r>
           </a:p>
           <a:p>
@@ -5225,7 +5225,7 @@
                   <a:srgbClr val="5B6770"/>
                 </a:solidFill>
               </a:rPr>
-              <a:t>CEN429 Güvenli Programlama · Hafta 16</a:t>
+              <a:t>CEN429 Secure Programming · Week 16</a:t>
             </a:r>
           </a:p>
         </p:txBody>
@@ -5258,7 +5258,7 @@
                   <a:srgbClr val="5B6770"/>
                 </a:solidFill>
               </a:rPr>
-              <a:t>RTEÜ Bilgisayar Mühendisliği · 2026-2027 Güz</a:t>
+              <a:t>RTEU Computer Engineering · 2026-2027 Fall</a:t>
             </a:r>
           </a:p>
         </p:txBody>
@@ -5325,7 +5325,7 @@
                   <a:srgbClr val="006D77"/>
                 </a:solidFill>
               </a:rPr>
-              <a:t>11. hafta · anahtar noktalar</a:t>
+              <a:t>Week 11 · Key Points</a:t>
             </a:r>
           </a:p>
         </p:txBody>
@@ -5371,7 +5371,7 @@
                   <a:srgbClr val="1F2D3A"/>
                 </a:solidFill>
               </a:rPr>
-              <a:t>Kara/gri/beyaz kutu.</a:t>
+              <a:t>Black/gray/white box.</a:t>
             </a:r>
           </a:p>
           <a:p>
@@ -5394,7 +5394,7 @@
                   <a:srgbClr val="1F2D3A"/>
                 </a:solidFill>
               </a:rPr>
-              <a:t>Tablo tabanlı WBC; iç/dış kodlama.</a:t>
+              <a:t>Table-based WBC; internal/external encoding.</a:t>
             </a:r>
           </a:p>
           <a:p>
@@ -5417,7 +5417,7 @@
                   <a:srgbClr val="1F2D3A"/>
                 </a:solidFill>
               </a:rPr>
-              <a:t>"Hepsi kırıldı" → WBC bir katman.</a:t>
+              <a:t>"All broken" → WBC is one layer.</a:t>
             </a:r>
           </a:p>
           <a:p>
@@ -5440,7 +5440,7 @@
                   <a:srgbClr val="1F2D3A"/>
                 </a:solidFill>
               </a:rPr>
-              <a:t>Anahtar yenileme + cihaz bağlama + sunucu.</a:t>
+              <a:t>Key renewal + device binding + server.</a:t>
             </a:r>
           </a:p>
         </p:txBody>
@@ -5515,7 +5515,7 @@
                   <a:srgbClr val="5B6770"/>
                 </a:solidFill>
               </a:rPr>
-              <a:t>CEN429 Güvenli Programlama · Hafta 16</a:t>
+              <a:t>CEN429 Secure Programming · Week 16</a:t>
             </a:r>
           </a:p>
         </p:txBody>
@@ -5548,7 +5548,7 @@
                   <a:srgbClr val="5B6770"/>
                 </a:solidFill>
               </a:rPr>
-              <a:t>RTEÜ Bilgisayar Mühendisliği · 2026-2027 Güz</a:t>
+              <a:t>RTEU Computer Engineering · 2026-2027 Fall</a:t>
             </a:r>
           </a:p>
         </p:txBody>
@@ -5615,7 +5615,7 @@
                   <a:srgbClr val="006D77"/>
                 </a:solidFill>
               </a:rPr>
-              <a:t>12. hafta · anahtar noktalar</a:t>
+              <a:t>Week 12 · Key Points</a:t>
             </a:r>
           </a:p>
         </p:txBody>
@@ -5661,7 +5661,7 @@
                   <a:srgbClr val="1F2D3A"/>
                 </a:solidFill>
               </a:rPr>
-              <a:t>13 adım değerlendirme.</a:t>
+              <a:t>13-step assessment.</a:t>
             </a:r>
           </a:p>
           <a:p>
@@ -5684,7 +5684,7 @@
                   <a:srgbClr val="1F2D3A"/>
                 </a:solidFill>
               </a:rPr>
-              <a:t>Saldırı potansiyeli + CVSS.</a:t>
+              <a:t>Attack potential + CVSS.</a:t>
             </a:r>
           </a:p>
           <a:p>
@@ -5707,7 +5707,7 @@
                   <a:srgbClr val="1F2D3A"/>
                 </a:solidFill>
               </a:rPr>
-              <a:t>Sızma testi planı; test kartı.</a:t>
+              <a:t>Penetration test plan; test card.</a:t>
             </a:r>
           </a:p>
           <a:p>
@@ -5730,7 +5730,7 @@
                   <a:srgbClr val="1F2D3A"/>
                 </a:solidFill>
               </a:rPr>
-              <a:t>Etki analizi vs delta.</a:t>
+              <a:t>Impact analysis vs. delta.</a:t>
             </a:r>
           </a:p>
         </p:txBody>
@@ -5805,7 +5805,7 @@
                   <a:srgbClr val="5B6770"/>
                 </a:solidFill>
               </a:rPr>
-              <a:t>CEN429 Güvenli Programlama · Hafta 16</a:t>
+              <a:t>CEN429 Secure Programming · Week 16</a:t>
             </a:r>
           </a:p>
         </p:txBody>
@@ -5838,7 +5838,7 @@
                   <a:srgbClr val="5B6770"/>
                 </a:solidFill>
               </a:rPr>
-              <a:t>RTEÜ Bilgisayar Mühendisliği · 2026-2027 Güz</a:t>
+              <a:t>RTEU Computer Engineering · 2026-2027 Fall</a:t>
             </a:r>
           </a:p>
         </p:txBody>
@@ -5905,7 +5905,7 @@
                   <a:srgbClr val="006D77"/>
                 </a:solidFill>
               </a:rPr>
-              <a:t>13. hafta · anahtar noktalar</a:t>
+              <a:t>Week 13 · Key Points</a:t>
             </a:r>
           </a:p>
         </p:txBody>
@@ -5951,7 +5951,7 @@
                   <a:srgbClr val="1F2D3A"/>
                 </a:solidFill>
               </a:rPr>
-              <a:t>İyi gereksinim; izlenebilirlik.</a:t>
+              <a:t>Good requirement; traceability.</a:t>
             </a:r>
           </a:p>
           <a:p>
@@ -5974,7 +5974,7 @@
                   <a:srgbClr val="1F2D3A"/>
                 </a:solidFill>
               </a:rPr>
-              <a:t>Uyum matrisi; devredilenler.</a:t>
+              <a:t>Compliance matrix; deferred requirements.</a:t>
             </a:r>
           </a:p>
           <a:p>
@@ -6095,7 +6095,7 @@
                   <a:srgbClr val="5B6770"/>
                 </a:solidFill>
               </a:rPr>
-              <a:t>CEN429 Güvenli Programlama · Hafta 16</a:t>
+              <a:t>CEN429 Secure Programming · Week 16</a:t>
             </a:r>
           </a:p>
         </p:txBody>
@@ -6128,7 +6128,7 @@
                   <a:srgbClr val="5B6770"/>
                 </a:solidFill>
               </a:rPr>
-              <a:t>RTEÜ Bilgisayar Mühendisliği · 2026-2027 Güz</a:t>
+              <a:t>RTEU Computer Engineering · 2026-2027 Fall</a:t>
             </a:r>
           </a:p>
         </p:txBody>
@@ -6195,7 +6195,7 @@
                   <a:srgbClr val="006D77"/>
                 </a:solidFill>
               </a:rPr>
-              <a:t>14. hafta · anahtar noktalar</a:t>
+              <a:t>Week 14 · Key Points</a:t>
             </a:r>
           </a:p>
         </p:txBody>
@@ -6241,7 +6241,7 @@
                   <a:srgbClr val="1F2D3A"/>
                 </a:solidFill>
               </a:rPr>
-              <a:t>Kaynaktan kaynağa (Tigress).</a:t>
+              <a:t>Source-to-source (Tigress).</a:t>
             </a:r>
           </a:p>
           <a:p>
@@ -6264,7 +6264,7 @@
                   <a:srgbClr val="1F2D3A"/>
                 </a:solidFill>
               </a:rPr>
-              <a:t>Dönüşüm hattı; tohumla çeşitlendirme.</a:t>
+              <a:t>Transformation pipeline; seed-based diversification.</a:t>
             </a:r>
           </a:p>
           <a:p>
@@ -6287,7 +6287,7 @@
                   <a:srgbClr val="1F2D3A"/>
                 </a:solidFill>
               </a:rPr>
-              <a:t>Maliyet + dayanıklılık ölçümü.</a:t>
+              <a:t>Cost + resilience measurement.</a:t>
             </a:r>
           </a:p>
           <a:p>
@@ -6310,7 +6310,7 @@
                   <a:srgbClr val="1F2D3A"/>
                 </a:solidFill>
               </a:rPr>
-              <a:t>Derleme hattı (S15).</a:t>
+              <a:t>Build pipeline (S15).</a:t>
             </a:r>
           </a:p>
         </p:txBody>
@@ -6385,7 +6385,7 @@
                   <a:srgbClr val="5B6770"/>
                 </a:solidFill>
               </a:rPr>
-              <a:t>CEN429 Güvenli Programlama · Hafta 16</a:t>
+              <a:t>CEN429 Secure Programming · Week 16</a:t>
             </a:r>
           </a:p>
         </p:txBody>
@@ -6418,7 +6418,7 @@
                   <a:srgbClr val="5B6770"/>
                 </a:solidFill>
               </a:rPr>
-              <a:t>RTEÜ Bilgisayar Mühendisliği · 2026-2027 Güz</a:t>
+              <a:t>RTEU Computer Engineering · 2026-2027 Fall</a:t>
             </a:r>
           </a:p>
         </p:txBody>
@@ -6485,7 +6485,7 @@
                   <a:srgbClr val="006D77"/>
                 </a:solidFill>
               </a:rPr>
-              <a:t>Sık karıştırılanlar</a:t>
+              <a:t>Frequently Confused</a:t>
             </a:r>
           </a:p>
         </p:txBody>
@@ -6509,9 +6509,9 @@
                 <a:tableStyleId>{5C22544A-7EE6-4342-B048-85BDC9FD1C3A}</a:tableStyleId>
               </a:tblPr>
               <a:tblGrid>
-                <a:gridCol w="2103428"/>
-                <a:gridCol w="3023678"/>
-                <a:gridCol w="5784428"/>
+                <a:gridCol w="2468085"/>
+                <a:gridCol w="2597984"/>
+                <a:gridCol w="5845465"/>
               </a:tblGrid>
               <a:tr h="401029">
                 <a:tc>
@@ -6567,7 +6567,7 @@
                             <a:srgbClr val="FFFFFF"/>
                           </a:solidFill>
                         </a:rPr>
-                        <a:t>Fark</a:t>
+                        <a:t>Difference</a:t>
                       </a:r>
                     </a:p>
                   </a:txBody>
@@ -6632,7 +6632,7 @@
                             <a:srgbClr val="1F2D3A"/>
                           </a:solidFill>
                         </a:rPr>
-                        <a:t>Dolgu / AEAD</a:t>
+                        <a:t>Padding / AEAD</a:t>
                       </a:r>
                     </a:p>
                   </a:txBody>
@@ -6697,7 +6697,7 @@
                             <a:srgbClr val="1F2D3A"/>
                           </a:solidFill>
                         </a:rPr>
-                        <a:t>Şifre / imza</a:t>
+                        <a:t>Encryption / signature</a:t>
                       </a:r>
                     </a:p>
                   </a:txBody>
@@ -6762,7 +6762,7 @@
                             <a:srgbClr val="1F2D3A"/>
                           </a:solidFill>
                         </a:rPr>
-                        <a:t>İmza / anahtar</a:t>
+                        <a:t>Signature / key</a:t>
                       </a:r>
                     </a:p>
                   </a:txBody>
@@ -6806,7 +6806,7 @@
                             <a:srgbClr val="1F2D3A"/>
                           </a:solidFill>
                         </a:rPr>
-                        <a:t>Saldırı potansiyeli</a:t>
+                        <a:t>Attack potential</a:t>
                       </a:r>
                     </a:p>
                   </a:txBody>
@@ -6827,7 +6827,7 @@
                             <a:srgbClr val="1F2D3A"/>
                           </a:solidFill>
                         </a:rPr>
-                        <a:t>Derinlik / saldırgan kaynağı</a:t>
+                        <a:t>Depth / attacker resources</a:t>
                       </a:r>
                     </a:p>
                   </a:txBody>
@@ -6850,7 +6850,7 @@
                             <a:srgbClr val="1F2D3A"/>
                           </a:solidFill>
                         </a:rPr>
-                        <a:t>Karşılandı</a:t>
+                        <a:t>Met</a:t>
                       </a:r>
                     </a:p>
                   </a:txBody>
@@ -6871,7 +6871,7 @@
                             <a:srgbClr val="1F2D3A"/>
                           </a:solidFill>
                         </a:rPr>
-                        <a:t>Devredildi</a:t>
+                        <a:t>Deferred</a:t>
                       </a:r>
                     </a:p>
                   </a:txBody>
@@ -6892,7 +6892,7 @@
                             <a:srgbClr val="1F2D3A"/>
                           </a:solidFill>
                         </a:rPr>
-                        <a:t>Ürün / başka taraf</a:t>
+                        <a:t>Product / another party</a:t>
                       </a:r>
                     </a:p>
                   </a:txBody>
@@ -6915,7 +6915,7 @@
                             <a:srgbClr val="1F2D3A"/>
                           </a:solidFill>
                         </a:rPr>
-                        <a:t>Etki analizi</a:t>
+                        <a:t>Impact analysis</a:t>
                       </a:r>
                     </a:p>
                   </a:txBody>
@@ -6957,7 +6957,7 @@
                             <a:srgbClr val="1F2D3A"/>
                           </a:solidFill>
                         </a:rPr>
-                        <a:t>Belgeler / yalnız değişeni değerlendirir</a:t>
+                        <a:t>Documents / re-assesses only what changed</a:t>
                       </a:r>
                     </a:p>
                   </a:txBody>
@@ -7042,7 +7042,7 @@
                   <a:srgbClr val="5B6770"/>
                 </a:solidFill>
               </a:rPr>
-              <a:t>CEN429 Güvenli Programlama · Hafta 16</a:t>
+              <a:t>CEN429 Secure Programming · Week 16</a:t>
             </a:r>
           </a:p>
         </p:txBody>
@@ -7075,7 +7075,7 @@
                   <a:srgbClr val="5B6770"/>
                 </a:solidFill>
               </a:rPr>
-              <a:t>RTEÜ Bilgisayar Mühendisliği · 2026-2027 Güz</a:t>
+              <a:t>RTEU Computer Engineering · 2026-2027 Fall</a:t>
             </a:r>
           </a:p>
         </p:txBody>
@@ -7142,7 +7142,7 @@
                   <a:srgbClr val="006D77"/>
                 </a:solidFill>
               </a:rPr>
-              <a:t>Final ve başarı notu — şema</a:t>
+              <a:t>Final and Course Passing Grade — Diagram</a:t>
             </a:r>
           </a:p>
         </p:txBody>
@@ -7225,7 +7225,7 @@
                   <a:srgbClr val="D8F0F2"/>
                 </a:solidFill>
               </a:rPr>
-              <a:t>CEN429 Güvenli Programlama · Hafta 16</a:t>
+              <a:t>CEN429 Secure Programming · Week 16</a:t>
             </a:r>
           </a:p>
         </p:txBody>
@@ -7258,7 +7258,7 @@
                   <a:srgbClr val="D8F0F2"/>
                 </a:solidFill>
               </a:rPr>
-              <a:t>RTEÜ Bilgisayar Mühendisliği · 2026-2027 Güz</a:t>
+              <a:t>RTEU Computer Engineering · 2026-2027 Fall</a:t>
             </a:r>
           </a:p>
         </p:txBody>
@@ -7326,7 +7326,7 @@
                   <a:srgbClr val="FFFFFF"/>
                 </a:solidFill>
               </a:rPr>
-              <a:t>Ek · Çözümlü pratik (9, 11, 14)</a:t>
+              <a:t>Appendix · Solved Practice (9, 11, 14)</a:t>
             </a:r>
           </a:p>
         </p:txBody>
@@ -7401,7 +7401,7 @@
                   <a:srgbClr val="5B6770"/>
                 </a:solidFill>
               </a:rPr>
-              <a:t>CEN429 Güvenli Programlama · Hafta 16</a:t>
+              <a:t>CEN429 Secure Programming · Week 16</a:t>
             </a:r>
           </a:p>
         </p:txBody>
@@ -7434,7 +7434,7 @@
                   <a:srgbClr val="5B6770"/>
                 </a:solidFill>
               </a:rPr>
-              <a:t>RTEÜ Bilgisayar Mühendisliği · 2026-2027 Güz</a:t>
+              <a:t>RTEU Computer Engineering · 2026-2027 Fall</a:t>
             </a:r>
           </a:p>
         </p:txBody>
@@ -7501,7 +7501,7 @@
                   <a:srgbClr val="006D77"/>
                 </a:solidFill>
               </a:rPr>
-              <a:t>Soru · 9. hafta</a:t>
+              <a:t>Question · Week 9</a:t>
             </a:r>
           </a:p>
         </p:txBody>
@@ -7535,7 +7535,7 @@
                   <a:srgbClr val="1F2D3A"/>
                 </a:solidFill>
               </a:rPr>
-              <a:t>Sahte işlem ile ölü dal farkı?</a:t>
+              <a:t>Difference between bogus code and dead code?</a:t>
             </a:r>
           </a:p>
         </p:txBody>
@@ -7569,7 +7569,7 @@
                   <a:srgbClr val="1F2D3A"/>
                 </a:solidFill>
               </a:rPr>
-              <a:t>Cevap:</a:t>
+              <a:t>Answer:</a:t>
             </a:r>
             <a:r>
               <a:rPr sz="2000" b="0">
@@ -7577,7 +7577,7 @@
                   <a:srgbClr val="1F2D3A"/>
                 </a:solidFill>
               </a:rPr>
-              <a:t> Sahte işlem çalışır ama sonucu değiştirmez; ölü dal opak yüklemle hiç çalışmaz. İkisi de gerçek mantığı gizler.</a:t>
+              <a:t> Bogus code executes but doesn't change the result; dead code with an opaque predicate never executes. Both hide the real logic.</a:t>
             </a:r>
           </a:p>
         </p:txBody>
@@ -7652,7 +7652,7 @@
                   <a:srgbClr val="5B6770"/>
                 </a:solidFill>
               </a:rPr>
-              <a:t>CEN429 Güvenli Programlama · Hafta 16</a:t>
+              <a:t>CEN429 Secure Programming · Week 16</a:t>
             </a:r>
           </a:p>
         </p:txBody>
@@ -7685,7 +7685,7 @@
                   <a:srgbClr val="5B6770"/>
                 </a:solidFill>
               </a:rPr>
-              <a:t>RTEÜ Bilgisayar Mühendisliği · 2026-2027 Güz</a:t>
+              <a:t>RTEU Computer Engineering · 2026-2027 Fall</a:t>
             </a:r>
           </a:p>
         </p:txBody>
@@ -7752,7 +7752,7 @@
                   <a:srgbClr val="006D77"/>
                 </a:solidFill>
               </a:rPr>
-              <a:t>Soru · 9. hafta</a:t>
+              <a:t>Question · Week 9</a:t>
             </a:r>
           </a:p>
         </p:txBody>
@@ -7786,7 +7786,7 @@
                   <a:srgbClr val="1F2D3A"/>
                 </a:solidFill>
               </a:rPr>
-              <a:t>Gizlemeyi ölçen dört boyut? Hangileri ödünleşir?</a:t>
+              <a:t>The four dimensions that measure obfuscation? Which ones trade off?</a:t>
             </a:r>
           </a:p>
         </p:txBody>
@@ -7820,7 +7820,7 @@
                   <a:srgbClr val="1F2D3A"/>
                 </a:solidFill>
               </a:rPr>
-              <a:t>Cevap:</a:t>
+              <a:t>Answer:</a:t>
             </a:r>
             <a:r>
               <a:rPr sz="2000" b="0">
@@ -7828,7 +7828,7 @@
                   <a:srgbClr val="1F2D3A"/>
                 </a:solidFill>
               </a:rPr>
-              <a:t> Güç, dayanıklılık, gizlilik, maliyet. Güç/dayanıklılık artarken maliyet artar, gizlilik azalır.</a:t>
+              <a:t> Potency, resilience, stealth, cost. As potency/resilience increase, cost increases and stealth decreases.</a:t>
             </a:r>
           </a:p>
         </p:txBody>
@@ -7903,7 +7903,7 @@
                   <a:srgbClr val="5B6770"/>
                 </a:solidFill>
               </a:rPr>
-              <a:t>CEN429 Güvenli Programlama · Hafta 16</a:t>
+              <a:t>CEN429 Secure Programming · Week 16</a:t>
             </a:r>
           </a:p>
         </p:txBody>
@@ -7936,7 +7936,7 @@
                   <a:srgbClr val="5B6770"/>
                 </a:solidFill>
               </a:rPr>
-              <a:t>RTEÜ Bilgisayar Mühendisliği · 2026-2027 Güz</a:t>
+              <a:t>RTEU Computer Engineering · 2026-2027 Fall</a:t>
             </a:r>
           </a:p>
         </p:txBody>
@@ -8003,7 +8003,7 @@
                   <a:srgbClr val="006D77"/>
                 </a:solidFill>
               </a:rPr>
-              <a:t>Soru · 11. hafta</a:t>
+              <a:t>Question · Week 11</a:t>
             </a:r>
           </a:p>
         </p:txBody>
@@ -8037,7 +8037,7 @@
                   <a:srgbClr val="1F2D3A"/>
                 </a:solidFill>
               </a:rPr>
-              <a:t>"Yayımlanmış saf-yazılım WBC'lerin hepsi kırıldı" kararınızı nasıl etkiler?</a:t>
+              <a:t>How does "all published pure-software WBCs have been broken" affect your decision?</a:t>
             </a:r>
           </a:p>
         </p:txBody>
@@ -8071,7 +8071,7 @@
                   <a:srgbClr val="1F2D3A"/>
                 </a:solidFill>
               </a:rPr>
-              <a:t>Cevap:</a:t>
+              <a:t>Answer:</a:t>
             </a:r>
             <a:r>
               <a:rPr sz="2000" b="0">
@@ -8079,7 +8079,7 @@
                   <a:srgbClr val="1F2D3A"/>
                 </a:solidFill>
               </a:rPr>
-              <a:t> WBC tek başına anahtar güvencesi sayılamaz; yenileme + cihaz bağlama + sunucu denetimi + gizleme ile; mümkünse donanıma taşı.</a:t>
+              <a:t> WBC alone cannot count as key assurance; combine with renewal + device binding + server checks + obfuscation; move to hardware where possible.</a:t>
             </a:r>
           </a:p>
         </p:txBody>
@@ -8154,7 +8154,7 @@
                   <a:srgbClr val="5B6770"/>
                 </a:solidFill>
               </a:rPr>
-              <a:t>CEN429 Güvenli Programlama · Hafta 16</a:t>
+              <a:t>CEN429 Secure Programming · Week 16</a:t>
             </a:r>
           </a:p>
         </p:txBody>
@@ -8187,7 +8187,7 @@
                   <a:srgbClr val="5B6770"/>
                 </a:solidFill>
               </a:rPr>
-              <a:t>RTEÜ Bilgisayar Mühendisliği · 2026-2027 Güz</a:t>
+              <a:t>RTEU Computer Engineering · 2026-2027 Fall</a:t>
             </a:r>
           </a:p>
         </p:txBody>
@@ -8254,7 +8254,7 @@
                   <a:srgbClr val="006D77"/>
                 </a:solidFill>
               </a:rPr>
-              <a:t>Soru · 11. hafta</a:t>
+              <a:t>Question · Week 11</a:t>
             </a:r>
           </a:p>
         </p:txBody>
@@ -8288,7 +8288,7 @@
                   <a:srgbClr val="1F2D3A"/>
                 </a:solidFill>
               </a:rPr>
-              <a:t>DCA hangi donanım saldırısına benzer?</a:t>
+              <a:t>Which hardware attack does DCA resemble?</a:t>
             </a:r>
           </a:p>
         </p:txBody>
@@ -8322,7 +8322,7 @@
                   <a:srgbClr val="1F2D3A"/>
                 </a:solidFill>
               </a:rPr>
-              <a:t>Cevap:</a:t>
+              <a:t>Answer:</a:t>
             </a:r>
             <a:r>
               <a:rPr sz="2000" b="0">
@@ -8330,7 +8330,7 @@
                   <a:srgbClr val="1F2D3A"/>
                 </a:solidFill>
               </a:rPr>
-              <a:t> DPA'ya (güç analizi); yazılım izlerine istatistik uygular, iç kodlamayı çoğu zaman aşar.</a:t>
+              <a:t> DPA (power analysis); it applies statistics to software traces and often defeats internal encoding.</a:t>
             </a:r>
           </a:p>
         </p:txBody>
@@ -8405,7 +8405,7 @@
                   <a:srgbClr val="5B6770"/>
                 </a:solidFill>
               </a:rPr>
-              <a:t>CEN429 Güvenli Programlama · Hafta 16</a:t>
+              <a:t>CEN429 Secure Programming · Week 16</a:t>
             </a:r>
           </a:p>
         </p:txBody>
@@ -8438,7 +8438,7 @@
                   <a:srgbClr val="5B6770"/>
                 </a:solidFill>
               </a:rPr>
-              <a:t>RTEÜ Bilgisayar Mühendisliği · 2026-2027 Güz</a:t>
+              <a:t>RTEU Computer Engineering · 2026-2027 Fall</a:t>
             </a:r>
           </a:p>
         </p:txBody>
@@ -8505,7 +8505,7 @@
                   <a:srgbClr val="006D77"/>
                 </a:solidFill>
               </a:rPr>
-              <a:t>Soru · 14. hafta</a:t>
+              <a:t>Question · Week 14</a:t>
             </a:r>
           </a:p>
         </p:txBody>
@@ -8539,7 +8539,7 @@
                   <a:srgbClr val="1F2D3A"/>
                 </a:solidFill>
               </a:rPr>
-              <a:t>Bir dönüşüm hattından sonra mutlaka yapılacak iki şey?</a:t>
+              <a:t>Two things that must always be done after a transformation pipeline?</a:t>
             </a:r>
           </a:p>
         </p:txBody>
@@ -8573,7 +8573,7 @@
                   <a:srgbClr val="1F2D3A"/>
                 </a:solidFill>
               </a:rPr>
-              <a:t>Cevap:</a:t>
+              <a:t>Answer:</a:t>
             </a:r>
             <a:r>
               <a:rPr sz="2000" b="0">
@@ -8581,7 +8581,7 @@
                   <a:srgbClr val="1F2D3A"/>
                 </a:solidFill>
               </a:rPr>
-              <a:t> Birim testleri (davranış korunmuş mu?) ve boyut/hız ölçümü (maliyet).</a:t>
+              <a:t> Unit tests (is behavior preserved?) and size/speed measurement (cost).</a:t>
             </a:r>
           </a:p>
         </p:txBody>
@@ -8656,7 +8656,7 @@
                   <a:srgbClr val="5B6770"/>
                 </a:solidFill>
               </a:rPr>
-              <a:t>CEN429 Güvenli Programlama · Hafta 16</a:t>
+              <a:t>CEN429 Secure Programming · Week 16</a:t>
             </a:r>
           </a:p>
         </p:txBody>
@@ -8689,7 +8689,7 @@
                   <a:srgbClr val="5B6770"/>
                 </a:solidFill>
               </a:rPr>
-              <a:t>RTEÜ Bilgisayar Mühendisliği · 2026-2027 Güz</a:t>
+              <a:t>RTEU Computer Engineering · 2026-2027 Fall</a:t>
             </a:r>
           </a:p>
         </p:txBody>
@@ -8756,7 +8756,7 @@
                   <a:srgbClr val="006D77"/>
                 </a:solidFill>
               </a:rPr>
-              <a:t>Soru · 14. hafta</a:t>
+              <a:t>Question · Week 14</a:t>
             </a:r>
           </a:p>
         </p:txBody>
@@ -8790,7 +8790,7 @@
                   <a:srgbClr val="1F2D3A"/>
                 </a:solidFill>
               </a:rPr>
-              <a:t>Tohum (`--Seed`) ne sağlar?</a:t>
+              <a:t>What does the seed (`--Seed`) provide?</a:t>
             </a:r>
           </a:p>
         </p:txBody>
@@ -8824,7 +8824,7 @@
                   <a:srgbClr val="1F2D3A"/>
                 </a:solidFill>
               </a:rPr>
-              <a:t>Cevap:</a:t>
+              <a:t>Answer:</a:t>
             </a:r>
             <a:r>
               <a:rPr sz="2000" b="0">
@@ -8832,7 +8832,7 @@
                   <a:srgbClr val="1F2D3A"/>
                 </a:solidFill>
               </a:rPr>
-              <a:t> Çeşitlendirme; aynı dönüşümler farklı tohumla farklı ikili üretir, bir kopyaya yazılan saldırı diğerinde çalışmaz.</a:t>
+              <a:t> Diversification; the same transformations produce a different binary with a different seed, so an attack written against one copy won't work on another.</a:t>
             </a:r>
           </a:p>
         </p:txBody>
@@ -8907,7 +8907,7 @@
                   <a:srgbClr val="5B6770"/>
                 </a:solidFill>
               </a:rPr>
-              <a:t>CEN429 Güvenli Programlama · Hafta 16</a:t>
+              <a:t>CEN429 Secure Programming · Week 16</a:t>
             </a:r>
           </a:p>
         </p:txBody>
@@ -8940,7 +8940,7 @@
                   <a:srgbClr val="5B6770"/>
                 </a:solidFill>
               </a:rPr>
-              <a:t>RTEÜ Bilgisayar Mühendisliği · 2026-2027 Güz</a:t>
+              <a:t>RTEU Computer Engineering · 2026-2027 Fall</a:t>
             </a:r>
           </a:p>
         </p:txBody>
@@ -9007,7 +9007,7 @@
                   <a:srgbClr val="006D77"/>
                 </a:solidFill>
               </a:rPr>
-              <a:t>Soru · 10. hafta</a:t>
+              <a:t>Question · Week 10</a:t>
             </a:r>
           </a:p>
         </p:txBody>
@@ -9041,7 +9041,7 @@
                   <a:srgbClr val="1F2D3A"/>
                 </a:solidFill>
               </a:rPr>
-              <a:t>Zincir doğrulamanın dört sorusu?</a:t>
+              <a:t>The four questions of chain validation?</a:t>
             </a:r>
           </a:p>
         </p:txBody>
@@ -9075,7 +9075,7 @@
                   <a:srgbClr val="1F2D3A"/>
                 </a:solidFill>
               </a:rPr>
-              <a:t>Cevap:</a:t>
+              <a:t>Answer:</a:t>
             </a:r>
             <a:r>
               <a:rPr sz="2000" b="0">
@@ -9083,7 +9083,7 @@
                   <a:srgbClr val="1F2D3A"/>
                 </a:solidFill>
               </a:rPr>
-              <a:t> İmza geçerli mi, güvenilir köke ulaşıyor mu, süre dolmamış mı, ad (SAN) eşleşiyor mu.</a:t>
+              <a:t> Is the signature valid, does it reach a trusted root, has it not expired, does the name (SAN) match.</a:t>
             </a:r>
           </a:p>
         </p:txBody>
@@ -9158,7 +9158,7 @@
                   <a:srgbClr val="5B6770"/>
                 </a:solidFill>
               </a:rPr>
-              <a:t>CEN429 Güvenli Programlama · Hafta 16</a:t>
+              <a:t>CEN429 Secure Programming · Week 16</a:t>
             </a:r>
           </a:p>
         </p:txBody>
@@ -9191,7 +9191,7 @@
                   <a:srgbClr val="5B6770"/>
                 </a:solidFill>
               </a:rPr>
-              <a:t>RTEÜ Bilgisayar Mühendisliği · 2026-2027 Güz</a:t>
+              <a:t>RTEU Computer Engineering · 2026-2027 Fall</a:t>
             </a:r>
           </a:p>
         </p:txBody>
@@ -9258,7 +9258,7 @@
                   <a:srgbClr val="006D77"/>
                 </a:solidFill>
               </a:rPr>
-              <a:t>Soru · 12–13. hafta</a:t>
+              <a:t>Question · Weeks 12–13</a:t>
             </a:r>
           </a:p>
         </p:txBody>
@@ -9292,7 +9292,7 @@
                   <a:srgbClr val="1F2D3A"/>
                 </a:solidFill>
               </a:rPr>
-              <a:t>"EAL4+ her zaman daha güvenli" doğru mu?</a:t>
+              <a:t>Is "EAL4+ is always more secure" true?</a:t>
             </a:r>
           </a:p>
         </p:txBody>
@@ -9306,7 +9306,7 @@
         <p:spPr>
           <a:xfrm>
             <a:off x="640080" y="1875536"/>
-            <a:ext cx="10911535" cy="439928"/>
+            <a:ext cx="10911535" cy="770128"/>
           </a:xfrm>
           <a:prstGeom prst="rect">
             <a:avLst/>
@@ -9326,7 +9326,7 @@
                   <a:srgbClr val="1F2D3A"/>
                 </a:solidFill>
               </a:rPr>
-              <a:t>Cevap:</a:t>
+              <a:t>Answer:</a:t>
             </a:r>
             <a:r>
               <a:rPr sz="2000" b="0">
@@ -9334,7 +9334,7 @@
                   <a:srgbClr val="1F2D3A"/>
                 </a:solidFill>
               </a:rPr>
-              <a:t> Hayır; EAL derinliktir, güvenlik ST'deki tehdit ve amaçlara bağlı.</a:t>
+              <a:t> No; EAL is depth, security depends on the threats and objectives in the ST.</a:t>
             </a:r>
           </a:p>
         </p:txBody>
@@ -9409,7 +9409,7 @@
                   <a:srgbClr val="5B6770"/>
                 </a:solidFill>
               </a:rPr>
-              <a:t>CEN429 Güvenli Programlama · Hafta 16</a:t>
+              <a:t>CEN429 Secure Programming · Week 16</a:t>
             </a:r>
           </a:p>
         </p:txBody>
@@ -9442,7 +9442,7 @@
                   <a:srgbClr val="5B6770"/>
                 </a:solidFill>
               </a:rPr>
-              <a:t>RTEÜ Bilgisayar Mühendisliği · 2026-2027 Güz</a:t>
+              <a:t>RTEU Computer Engineering · 2026-2027 Fall</a:t>
             </a:r>
           </a:p>
         </p:txBody>
@@ -9509,7 +9509,7 @@
                   <a:srgbClr val="006D77"/>
                 </a:solidFill>
               </a:rPr>
-              <a:t>Örnek · çoktan seçmeli</a:t>
+              <a:t>Example · Multiple Choice</a:t>
             </a:r>
           </a:p>
         </p:txBody>
@@ -9543,7 +9543,7 @@
                   <a:srgbClr val="1F2D3A"/>
                 </a:solidFill>
               </a:rPr>
-              <a:t>Whitebox kriptografide dış kodlamanın (F,G) sınırı nedir?</a:t>
+              <a:t>What is the limit of external encoding (F,G) in white-box cryptography?</a:t>
             </a:r>
           </a:p>
         </p:txBody>
@@ -9577,7 +9577,7 @@
                   <a:srgbClr val="1F2D3A"/>
                 </a:solidFill>
               </a:rPr>
-              <a:t>A) Çok yavaş B) </a:t>
+              <a:t>A) Too slow B) </a:t>
             </a:r>
             <a:r>
               <a:rPr sz="2000" b="1">
@@ -9585,7 +9585,7 @@
                   <a:srgbClr val="1F2D3A"/>
                 </a:solidFill>
               </a:rPr>
-              <a:t>Standart AES değil</a:t>
+              <a:t>Not standard AES</a:t>
             </a:r>
             <a:r>
               <a:rPr sz="2000" b="0">
@@ -9593,7 +9593,7 @@
                   <a:srgbClr val="1F2D3A"/>
                 </a:solidFill>
               </a:rPr>
-              <a:t> ✓ C) Tablo küçük D) Anahtar açık</a:t>
+              <a:t> ✓ C) Table too small D) Key exposed</a:t>
             </a:r>
           </a:p>
         </p:txBody>
@@ -9668,7 +9668,7 @@
                   <a:srgbClr val="5B6770"/>
                 </a:solidFill>
               </a:rPr>
-              <a:t>CEN429 Güvenli Programlama · Hafta 16</a:t>
+              <a:t>CEN429 Secure Programming · Week 16</a:t>
             </a:r>
           </a:p>
         </p:txBody>
@@ -9701,7 +9701,7 @@
                   <a:srgbClr val="5B6770"/>
                 </a:solidFill>
               </a:rPr>
-              <a:t>RTEÜ Bilgisayar Mühendisliği · 2026-2027 Güz</a:t>
+              <a:t>RTEU Computer Engineering · 2026-2027 Fall</a:t>
             </a:r>
           </a:p>
         </p:txBody>
@@ -9768,7 +9768,7 @@
                   <a:srgbClr val="006D77"/>
                 </a:solidFill>
               </a:rPr>
-              <a:t>Quiz-2: ne, ne zaman?</a:t>
+              <a:t>Quiz-2: What, When?</a:t>
             </a:r>
           </a:p>
         </p:txBody>
@@ -9814,7 +9814,7 @@
                   <a:srgbClr val="1F2D3A"/>
                 </a:solidFill>
               </a:rPr>
-              <a:t>Kapsam: </a:t>
+              <a:t>Scope: </a:t>
             </a:r>
             <a:r>
               <a:rPr sz="2000" b="1">
@@ -9822,7 +9822,7 @@
                   <a:srgbClr val="1F2D3A"/>
                 </a:solidFill>
               </a:rPr>
-              <a:t>9–14. haftalar</a:t>
+              <a:t>weeks 9–14</a:t>
             </a:r>
             <a:r>
               <a:rPr sz="2000" b="0">
@@ -9830,7 +9830,7 @@
                   <a:srgbClr val="1F2D3A"/>
                 </a:solidFill>
               </a:rPr>
-              <a:t> · finalin </a:t>
+              <a:t> · </a:t>
             </a:r>
             <a:r>
               <a:rPr sz="2000" b="1">
@@ -9838,7 +9838,7 @@
                   <a:srgbClr val="1F2D3A"/>
                 </a:solidFill>
               </a:rPr>
-              <a:t>%30</a:t>
+              <a:t>30%</a:t>
             </a:r>
             <a:r>
               <a:rPr sz="2000" b="0">
@@ -9846,7 +9846,7 @@
                   <a:srgbClr val="1F2D3A"/>
                 </a:solidFill>
               </a:rPr>
-              <a:t>'u</a:t>
+              <a:t> of the final grade</a:t>
             </a:r>
           </a:p>
           <a:p>
@@ -9869,7 +9869,7 @@
                   <a:srgbClr val="1F2D3A"/>
                 </a:solidFill>
               </a:rPr>
-              <a:t>Tarih, saat, yer, süre, biçim: </a:t>
+              <a:t>Date, time, place, duration, format: </a:t>
             </a:r>
             <a:r>
               <a:rPr sz="2000" b="1">
@@ -9877,7 +9877,7 @@
                   <a:srgbClr val="1F2D3A"/>
                 </a:solidFill>
               </a:rPr>
-              <a:t>ders sınıfında</a:t>
+              <a:t>announced in class</a:t>
             </a:r>
           </a:p>
           <a:p>
@@ -9900,7 +9900,7 @@
                   <a:srgbClr val="1F2D3A"/>
                 </a:solidFill>
               </a:rPr>
-              <a:t>En iyi hazırlık: Kendini sınama soruları · 10. hafta OpenSSL adımları · 13. hafta uyum matrisi</a:t>
+              <a:t>Best preparation: Self-check questions · Week 10 OpenSSL steps · Week 13 compliance matrix</a:t>
             </a:r>
           </a:p>
         </p:txBody>
@@ -9975,7 +9975,7 @@
                   <a:srgbClr val="5B6770"/>
                 </a:solidFill>
               </a:rPr>
-              <a:t>CEN429 Güvenli Programlama · Hafta 16</a:t>
+              <a:t>CEN429 Secure Programming · Week 16</a:t>
             </a:r>
           </a:p>
         </p:txBody>
@@ -10008,7 +10008,7 @@
                   <a:srgbClr val="5B6770"/>
                 </a:solidFill>
               </a:rPr>
-              <a:t>RTEÜ Bilgisayar Mühendisliği · 2026-2027 Güz</a:t>
+              <a:t>RTEU Computer Engineering · 2026-2027 Fall</a:t>
             </a:r>
           </a:p>
         </p:txBody>
@@ -10075,7 +10075,7 @@
                   <a:srgbClr val="006D77"/>
                 </a:solidFill>
               </a:rPr>
-              <a:t>Çalışma planı</a:t>
+              <a:t>Study Plan</a:t>
             </a:r>
           </a:p>
         </p:txBody>
@@ -10121,7 +10121,7 @@
                   <a:srgbClr val="1F2D3A"/>
                 </a:solidFill>
               </a:rPr>
-              <a:t>9, 11, 14. hafta sayfalarındaki çözümlü sınamaları yap.</a:t>
+              <a:t>Do the solved practice items on the Week 9, 11, and 14 pages.</a:t>
             </a:r>
           </a:p>
           <a:p>
@@ -10144,7 +10144,7 @@
                   <a:srgbClr val="1F2D3A"/>
                 </a:solidFill>
               </a:rPr>
-              <a:t>10. haftanın OpenSSL adımlarını tekrar et.</a:t>
+              <a:t>Review the Week 10 OpenSSL steps.</a:t>
             </a:r>
           </a:p>
           <a:p>
@@ -10167,7 +10167,7 @@
                   <a:srgbClr val="1F2D3A"/>
                 </a:solidFill>
               </a:rPr>
-              <a:t>13. haftanın uyum matrisi etkinliğini kendin doldur.</a:t>
+              <a:t>Fill in the Week 13 compliance matrix activity yourself.</a:t>
             </a:r>
           </a:p>
         </p:txBody>
@@ -10242,7 +10242,7 @@
                   <a:srgbClr val="5B6770"/>
                 </a:solidFill>
               </a:rPr>
-              <a:t>CEN429 Güvenli Programlama · Hafta 16</a:t>
+              <a:t>CEN429 Secure Programming · Week 16</a:t>
             </a:r>
           </a:p>
         </p:txBody>
@@ -10275,7 +10275,7 @@
                   <a:srgbClr val="5B6770"/>
                 </a:solidFill>
               </a:rPr>
-              <a:t>RTEÜ Bilgisayar Mühendisliği · 2026-2027 Güz</a:t>
+              <a:t>RTEU Computer Engineering · 2026-2027 Fall</a:t>
             </a:r>
           </a:p>
         </p:txBody>
@@ -10342,7 +10342,7 @@
                   <a:srgbClr val="006D77"/>
                 </a:solidFill>
               </a:rPr>
-              <a:t>Son söz (Quiz-2 hazırlık)</a:t>
+              <a:t>Final Word (Quiz-2 Prep)</a:t>
             </a:r>
           </a:p>
         </p:txBody>
@@ -10356,7 +10356,7 @@
         <p:spPr>
           <a:xfrm>
             <a:off x="640080" y="1325880"/>
-            <a:ext cx="10911535" cy="604520"/>
+            <a:ext cx="10911535" cy="934719"/>
           </a:xfrm>
           <a:prstGeom prst="rect">
             <a:avLst/>
@@ -10395,7 +10395,7 @@
                   <a:srgbClr val="1F2D3A"/>
                 </a:solidFill>
               </a:rPr>
-              <a:t>Koruma = </a:t>
+              <a:t>Protection = </a:t>
             </a:r>
             <a:r>
               <a:rPr sz="2000" b="1">
@@ -10403,7 +10403,7 @@
                   <a:srgbClr val="1F2D3A"/>
                 </a:solidFill>
               </a:rPr>
-              <a:t>gecikme</a:t>
+              <a:t>delay</a:t>
             </a:r>
             <a:r>
               <a:rPr sz="2000" b="0">
@@ -10411,7 +10411,7 @@
                   <a:srgbClr val="1F2D3A"/>
                 </a:solidFill>
               </a:rPr>
-              <a:t>; güç katmandan ve </a:t>
+              <a:t>; strength comes from layering and </a:t>
             </a:r>
             <a:r>
               <a:rPr sz="2000" b="1">
@@ -10419,7 +10419,7 @@
                   <a:srgbClr val="1F2D3A"/>
                 </a:solidFill>
               </a:rPr>
-              <a:t>ölçümden</a:t>
+              <a:t>measurement</a:t>
             </a:r>
             <a:r>
               <a:rPr sz="2000" b="0">
@@ -10427,7 +10427,7 @@
                   <a:srgbClr val="1F2D3A"/>
                 </a:solidFill>
               </a:rPr>
-              <a:t>. Ezber değil, gerekçe ölçülür.</a:t>
+              <a:t>. Reasoning is measured, not memorized.</a:t>
             </a:r>
           </a:p>
         </p:txBody>
@@ -10440,7 +10440,7 @@
         </p:nvSpPr>
         <p:spPr>
           <a:xfrm>
-            <a:off x="640080" y="2040128"/>
+            <a:off x="640080" y="2370328"/>
             <a:ext cx="10911535" cy="439928"/>
           </a:xfrm>
           <a:prstGeom prst="rect">
@@ -10461,7 +10461,7 @@
                   <a:srgbClr val="1F2D3A"/>
                 </a:solidFill>
               </a:rPr>
-              <a:t>İyi şanslar.</a:t>
+              <a:t>Good luck.</a:t>
             </a:r>
           </a:p>
         </p:txBody>
@@ -10536,7 +10536,7 @@
                   <a:srgbClr val="5B6770"/>
                 </a:solidFill>
               </a:rPr>
-              <a:t>CEN429 Güvenli Programlama · Hafta 16</a:t>
+              <a:t>CEN429 Secure Programming · Week 16</a:t>
             </a:r>
           </a:p>
         </p:txBody>
@@ -10569,7 +10569,7 @@
                   <a:srgbClr val="5B6770"/>
                 </a:solidFill>
               </a:rPr>
-              <a:t>RTEÜ Bilgisayar Mühendisliği · 2026-2027 Güz</a:t>
+              <a:t>RTEU Computer Engineering · 2026-2027 Fall</a:t>
             </a:r>
           </a:p>
         </p:txBody>
@@ -10636,7 +10636,7 @@
                   <a:srgbClr val="006D77"/>
                 </a:solidFill>
               </a:rPr>
-              <a:t>Konu haritası</a:t>
+              <a:t>Topic Map</a:t>
             </a:r>
           </a:p>
         </p:txBody>
@@ -10660,8 +10660,8 @@
                 <a:tableStyleId>{5C22544A-7EE6-4342-B048-85BDC9FD1C3A}</a:tableStyleId>
               </a:tblPr>
               <a:tblGrid>
-                <a:gridCol w="677267"/>
-                <a:gridCol w="10234267"/>
+                <a:gridCol w="606196"/>
+                <a:gridCol w="10305338"/>
               </a:tblGrid>
               <a:tr h="526694">
                 <a:tc>
@@ -10675,7 +10675,7 @@
                             <a:srgbClr val="FFFFFF"/>
                           </a:solidFill>
                         </a:rPr>
-                        <a:t>Hafta</a:t>
+                        <a:t>Week</a:t>
                       </a:r>
                     </a:p>
                   </a:txBody>
@@ -10696,7 +10696,7 @@
                             <a:srgbClr val="FFFFFF"/>
                           </a:solidFill>
                         </a:rPr>
-                        <a:t>Odak</a:t>
+                        <a:t>Focus</a:t>
                       </a:r>
                     </a:p>
                   </a:txBody>
@@ -10740,7 +10740,7 @@
                             <a:srgbClr val="1F2D3A"/>
                           </a:solidFill>
                         </a:rPr>
-                        <a:t>Gizlemenin amacı, maliyeti, ölçülmesi (güç, dayanıklılık, maliyet)</a:t>
+                        <a:t>Purpose, cost, and measurement of obfuscation (potency, resilience, cost)</a:t>
                       </a:r>
                     </a:p>
                   </a:txBody>
@@ -10784,7 +10784,7 @@
                             <a:srgbClr val="1F2D3A"/>
                           </a:solidFill>
                         </a:rPr>
-                        <a:t>Güvenlik düzeyi · kip ve dolgu · HMAC, EtM, yeniden oynatma · OAEP/PSS, Ed25519/X25519 · imza · DH · PKI, X.509 · CRL/OCSP · PKCS#11</a:t>
+                        <a:t>Security level · modes and padding · HMAC, EtM, replay · OAEP/PSS, Ed25519/X25519 · signature · DH · PKI, X.509 · CRL/OCSP · PKCS#11</a:t>
                       </a:r>
                     </a:p>
                   </a:txBody>
@@ -10828,7 +10828,7 @@
                             <a:srgbClr val="1F2D3A"/>
                           </a:solidFill>
                         </a:rPr>
-                        <a:t>Beyaz/kara kutu modelleri · whitebox'ın katmanlı savunmadaki yeri ve sınırları</a:t>
+                        <a:t>White-box/black-box models · white-box's role and limits in layered defense</a:t>
                       </a:r>
                     </a:p>
                   </a:txBody>
@@ -10872,7 +10872,7 @@
                             <a:srgbClr val="1F2D3A"/>
                           </a:solidFill>
                         </a:rPr>
-                        <a:t>13 adım · gereksinim şablonu · bulgu–aksiyon · etki analizi · delta değerlendirme</a:t>
+                        <a:t>13 steps · requirement template · finding–action · impact analysis · delta assessment</a:t>
                       </a:r>
                     </a:p>
                   </a:txBody>
@@ -10916,7 +10916,7 @@
                             <a:srgbClr val="1F2D3A"/>
                           </a:solidFill>
                         </a:rPr>
-                        <a:t>İyi gereksinim · uyum matrisi · devredilenler · CC, EAL · FIPS 140-3 · ETSI, EMVCo, PCI, MASVS</a:t>
+                        <a:t>Good requirement · compliance matrix · deferred requirements · CC, EAL · FIPS 140-3 · ETSI, EMVCo, PCI, MASVS</a:t>
                       </a:r>
                     </a:p>
                   </a:txBody>
@@ -10960,7 +10960,7 @@
                             <a:srgbClr val="1F2D3A"/>
                           </a:solidFill>
                         </a:rPr>
-                        <a:t>Çeşitlendirmenin amacı · maliyet ve etkinlik ölçümü</a:t>
+                        <a:t>Purpose of diversification · measuring cost and effectiveness</a:t>
                       </a:r>
                     </a:p>
                   </a:txBody>
@@ -11045,7 +11045,7 @@
                   <a:srgbClr val="5B6770"/>
                 </a:solidFill>
               </a:rPr>
-              <a:t>CEN429 Güvenli Programlama · Hafta 16</a:t>
+              <a:t>CEN429 Secure Programming · Week 16</a:t>
             </a:r>
           </a:p>
         </p:txBody>
@@ -11078,7 +11078,7 @@
                   <a:srgbClr val="5B6770"/>
                 </a:solidFill>
               </a:rPr>
-              <a:t>RTEÜ Bilgisayar Mühendisliği · 2026-2027 Güz</a:t>
+              <a:t>RTEU Computer Engineering · 2026-2027 Fall</a:t>
             </a:r>
           </a:p>
         </p:txBody>
@@ -11145,7 +11145,7 @@
                   <a:srgbClr val="006D77"/>
                 </a:solidFill>
               </a:rPr>
-              <a:t>Quiz-2 kapsamı — şema</a:t>
+              <a:t>Quiz-2 Scope — Diagram</a:t>
             </a:r>
           </a:p>
         </p:txBody>
@@ -11244,7 +11244,7 @@
                   <a:srgbClr val="5B6770"/>
                 </a:solidFill>
               </a:rPr>
-              <a:t>CEN429 Güvenli Programlama · Hafta 16</a:t>
+              <a:t>CEN429 Secure Programming · Week 16</a:t>
             </a:r>
           </a:p>
         </p:txBody>
@@ -11277,7 +11277,7 @@
                   <a:srgbClr val="5B6770"/>
                 </a:solidFill>
               </a:rPr>
-              <a:t>RTEÜ Bilgisayar Mühendisliği · 2026-2027 Güz</a:t>
+              <a:t>RTEU Computer Engineering · 2026-2027 Fall</a:t>
             </a:r>
           </a:p>
         </p:txBody>
@@ -11344,7 +11344,7 @@
                   <a:srgbClr val="006D77"/>
                 </a:solidFill>
               </a:rPr>
-              <a:t>Sık karıştırılanlar</a:t>
+              <a:t>Frequently Confused</a:t>
             </a:r>
           </a:p>
         </p:txBody>
@@ -11359,7 +11359,7 @@
         </p:nvGraphicFramePr>
         <p:xfrm>
           <a:off x="640080" y="1325880"/>
-          <a:ext cx="10911533" cy="3588105"/>
+          <a:ext cx="10911533" cy="4016044"/>
         </p:xfrm>
         <a:graphic>
           <a:graphicData uri="http://schemas.openxmlformats.org/drawingml/2006/table">
@@ -11368,11 +11368,11 @@
                 <a:tableStyleId>{5C22544A-7EE6-4342-B048-85BDC9FD1C3A}</a:tableStyleId>
               </a:tblPr>
               <a:tblGrid>
-                <a:gridCol w="1918511"/>
-                <a:gridCol w="2757860"/>
+                <a:gridCol w="2278232"/>
+                <a:gridCol w="2398139"/>
                 <a:gridCol w="6235162"/>
               </a:tblGrid>
-              <a:tr h="358810">
+              <a:tr h="401604">
                 <a:tc>
                   <a:txBody>
                     <a:bodyPr wrap="square"/>
@@ -11426,7 +11426,7 @@
                             <a:srgbClr val="FFFFFF"/>
                           </a:solidFill>
                         </a:rPr>
-                        <a:t>Fark</a:t>
+                        <a:t>Difference</a:t>
                       </a:r>
                     </a:p>
                   </a:txBody>
@@ -11437,7 +11437,7 @@
                   </a:tcPr>
                 </a:tc>
               </a:tr>
-              <a:tr h="358810">
+              <a:tr h="401604">
                 <a:tc>
                   <a:txBody>
                     <a:bodyPr wrap="square"/>
@@ -11491,7 +11491,7 @@
                             <a:srgbClr val="1F2D3A"/>
                           </a:solidFill>
                         </a:rPr>
-                        <a:t>Gizlilik + dolgu · AEAD, dolgu yok</a:t>
+                        <a:t>Confidentiality + padding · AEAD, no padding</a:t>
                       </a:r>
                     </a:p>
                   </a:txBody>
@@ -11502,7 +11502,7 @@
                   </a:tcPr>
                 </a:tc>
               </a:tr>
-              <a:tr h="358810">
+              <a:tr h="401604">
                 <a:tc>
                   <a:txBody>
                     <a:bodyPr wrap="square"/>
@@ -11556,7 +11556,7 @@
                             <a:srgbClr val="1F2D3A"/>
                           </a:solidFill>
                         </a:rPr>
-                        <a:t>Şifreleme · imza</a:t>
+                        <a:t>Encryption · signature</a:t>
                       </a:r>
                     </a:p>
                   </a:txBody>
@@ -11567,7 +11567,7 @@
                   </a:tcPr>
                 </a:tc>
               </a:tr>
-              <a:tr h="358810">
+              <a:tr h="401604">
                 <a:tc>
                   <a:txBody>
                     <a:bodyPr wrap="square"/>
@@ -11621,7 +11621,7 @@
                             <a:srgbClr val="1F2D3A"/>
                           </a:solidFill>
                         </a:rPr>
-                        <a:t>İmza · anahtar anlaşması</a:t>
+                        <a:t>Signature · key agreement</a:t>
                       </a:r>
                     </a:p>
                   </a:txBody>
@@ -11632,7 +11632,7 @@
                   </a:tcPr>
                 </a:tc>
               </a:tr>
-              <a:tr h="358810">
+              <a:tr h="401604">
                 <a:tc>
                   <a:txBody>
                     <a:bodyPr wrap="square"/>
@@ -11686,7 +11686,7 @@
                             <a:srgbClr val="1F2D3A"/>
                           </a:solidFill>
                         </a:rPr>
-                        <a:t>Ad denetimi SAN'a</a:t>
+                        <a:t>Name check → SAN</a:t>
                       </a:r>
                     </a:p>
                   </a:txBody>
@@ -11697,7 +11697,7 @@
                   </a:tcPr>
                 </a:tc>
               </a:tr>
-              <a:tr h="358810">
+              <a:tr h="401604">
                 <a:tc>
                   <a:txBody>
                     <a:bodyPr wrap="square"/>
@@ -11751,7 +11751,7 @@
                             <a:srgbClr val="1F2D3A"/>
                           </a:solidFill>
                         </a:rPr>
-                        <a:t>Liste · anlık sorgu</a:t>
+                        <a:t>List · live query</a:t>
                       </a:r>
                     </a:p>
                   </a:txBody>
@@ -11762,7 +11762,7 @@
                   </a:tcPr>
                 </a:tc>
               </a:tr>
-              <a:tr h="358810">
+              <a:tr h="401604">
                 <a:tc>
                   <a:txBody>
                     <a:bodyPr wrap="square"/>
@@ -11816,7 +11816,7 @@
                             <a:srgbClr val="1F2D3A"/>
                           </a:solidFill>
                         </a:rPr>
-                        <a:t>Ürün hedefi · ürün sınıfı seti</a:t>
+                        <a:t>Security target · product class requirement set</a:t>
                       </a:r>
                     </a:p>
                   </a:txBody>
@@ -11827,7 +11827,7 @@
                   </a:tcPr>
                 </a:tc>
               </a:tr>
-              <a:tr h="358810">
+              <a:tr h="401604">
                 <a:tc>
                   <a:txBody>
                     <a:bodyPr wrap="square"/>
@@ -11860,7 +11860,7 @@
                             <a:srgbClr val="1F2D3A"/>
                           </a:solidFill>
                         </a:rPr>
-                        <a:t>Saldırı potansiyeli</a:t>
+                        <a:t>Attack potential</a:t>
                       </a:r>
                     </a:p>
                   </a:txBody>
@@ -11881,7 +11881,7 @@
                             <a:srgbClr val="1F2D3A"/>
                           </a:solidFill>
                         </a:rPr>
-                        <a:t>Derinlik · saldırganın kaynağı</a:t>
+                        <a:t>Depth · attacker's resources</a:t>
                       </a:r>
                     </a:p>
                   </a:txBody>
@@ -11892,7 +11892,7 @@
                   </a:tcPr>
                 </a:tc>
               </a:tr>
-              <a:tr h="358810">
+              <a:tr h="401604">
                 <a:tc>
                   <a:txBody>
                     <a:bodyPr wrap="square"/>
@@ -11904,7 +11904,7 @@
                             <a:srgbClr val="1F2D3A"/>
                           </a:solidFill>
                         </a:rPr>
-                        <a:t>Karşılandı</a:t>
+                        <a:t>Met</a:t>
                       </a:r>
                     </a:p>
                   </a:txBody>
@@ -11925,7 +11925,7 @@
                             <a:srgbClr val="1F2D3A"/>
                           </a:solidFill>
                         </a:rPr>
-                        <a:t>Devredildi</a:t>
+                        <a:t>Deferred</a:t>
                       </a:r>
                     </a:p>
                   </a:txBody>
@@ -11946,7 +11946,7 @@
                             <a:srgbClr val="1F2D3A"/>
                           </a:solidFill>
                         </a:rPr>
-                        <a:t>Ürün karşılar · başka taraf (kime, neden, nasıl)</a:t>
+                        <a:t>Product meets it · another party (who, why, how)</a:t>
                       </a:r>
                     </a:p>
                   </a:txBody>
@@ -11957,7 +11957,7 @@
                   </a:tcPr>
                 </a:tc>
               </a:tr>
-              <a:tr h="358815">
+              <a:tr h="401608">
                 <a:tc>
                   <a:txBody>
                     <a:bodyPr wrap="square"/>
@@ -11969,7 +11969,7 @@
                             <a:srgbClr val="1F2D3A"/>
                           </a:solidFill>
                         </a:rPr>
-                        <a:t>Etki analizi</a:t>
+                        <a:t>Impact analysis</a:t>
                       </a:r>
                     </a:p>
                   </a:txBody>
@@ -11990,7 +11990,7 @@
                             <a:srgbClr val="1F2D3A"/>
                           </a:solidFill>
                         </a:rPr>
-                        <a:t>Delta değerlendirme</a:t>
+                        <a:t>Delta assessment</a:t>
                       </a:r>
                     </a:p>
                   </a:txBody>
@@ -12011,7 +12011,7 @@
                             <a:srgbClr val="1F2D3A"/>
                           </a:solidFill>
                         </a:rPr>
-                        <a:t>Belgeler · yalnız değişeni değerlendirir</a:t>
+                        <a:t>Documents · re-assesses only what changed</a:t>
                       </a:r>
                     </a:p>
                   </a:txBody>
@@ -12096,7 +12096,7 @@
                   <a:srgbClr val="5B6770"/>
                 </a:solidFill>
               </a:rPr>
-              <a:t>CEN429 Güvenli Programlama · Hafta 16</a:t>
+              <a:t>CEN429 Secure Programming · Week 16</a:t>
             </a:r>
           </a:p>
         </p:txBody>
@@ -12129,7 +12129,7 @@
                   <a:srgbClr val="5B6770"/>
                 </a:solidFill>
               </a:rPr>
-              <a:t>RTEÜ Bilgisayar Mühendisliği · 2026-2027 Güz</a:t>
+              <a:t>RTEU Computer Engineering · 2026-2027 Fall</a:t>
             </a:r>
           </a:p>
         </p:txBody>
@@ -12196,7 +12196,7 @@
                   <a:srgbClr val="006D77"/>
                 </a:solidFill>
               </a:rPr>
-              <a:t>Cevap kalıbı — şema</a:t>
+              <a:t>Answer Pattern — Diagram</a:t>
             </a:r>
           </a:p>
         </p:txBody>
@@ -12295,7 +12295,7 @@
                   <a:srgbClr val="5B6770"/>
                 </a:solidFill>
               </a:rPr>
-              <a:t>CEN429 Güvenli Programlama · Hafta 16</a:t>
+              <a:t>CEN429 Secure Programming · Week 16</a:t>
             </a:r>
           </a:p>
         </p:txBody>
@@ -12328,7 +12328,7 @@
                   <a:srgbClr val="5B6770"/>
                 </a:solidFill>
               </a:rPr>
-              <a:t>RTEÜ Bilgisayar Mühendisliği · 2026-2027 Güz</a:t>
+              <a:t>RTEU Computer Engineering · 2026-2027 Fall</a:t>
             </a:r>
           </a:p>
         </p:txBody>
@@ -12395,7 +12395,7 @@
                   <a:srgbClr val="006D77"/>
                 </a:solidFill>
               </a:rPr>
-              <a:t>Örnek sorular (10. hafta)</a:t>
+              <a:t>Sample Questions (Week 10)</a:t>
             </a:r>
           </a:p>
         </p:txBody>
@@ -12441,7 +12441,7 @@
                   <a:srgbClr val="1F2D3A"/>
                 </a:solidFill>
               </a:rPr>
-              <a:t>RSA-2048 + AES-256: güvenlik düzeyi?</a:t>
+              <a:t>RSA-2048 + AES-256: security level?</a:t>
             </a:r>
           </a:p>
           <a:p>
@@ -12464,7 +12464,7 @@
                   <a:srgbClr val="1F2D3A"/>
                 </a:solidFill>
               </a:rPr>
-              <a:t>"Dolgu geçersiz" ile "MAC geçersiz" ayrı iletiler: risk?</a:t>
+              <a:t>"Padding invalid" vs. "MAC invalid" as separate messages: risk?</a:t>
             </a:r>
           </a:p>
           <a:p>
@@ -12484,6 +12484,14 @@
             <a:r>
               <a:rPr sz="1800" b="0">
                 <a:solidFill>
+                  <a:srgbClr val="1F2D3A"/>
+                </a:solidFill>
+              </a:rPr>
+              <a:t>Why is </a:t>
+            </a:r>
+            <a:r>
+              <a:rPr sz="1800" b="0">
+                <a:solidFill>
                   <a:srgbClr val="A1123F"/>
                 </a:solidFill>
                 <a:latin typeface="Consolas"/>
@@ -12496,7 +12504,7 @@
                   <a:srgbClr val="1F2D3A"/>
                 </a:solidFill>
               </a:rPr>
-              <a:t> neden hatalı?</a:t>
+              <a:t> wrong?</a:t>
             </a:r>
           </a:p>
           <a:p>
@@ -12516,6 +12524,14 @@
             <a:r>
               <a:rPr sz="1800" b="0">
                 <a:solidFill>
+                  <a:srgbClr val="1F2D3A"/>
+                </a:solidFill>
+              </a:rPr>
+              <a:t>Why does </a:t>
+            </a:r>
+            <a:r>
+              <a:rPr sz="1800" b="0">
+                <a:solidFill>
                   <a:srgbClr val="A1123F"/>
                 </a:solidFill>
                 <a:latin typeface="Consolas"/>
@@ -12528,7 +12544,7 @@
                   <a:srgbClr val="1F2D3A"/>
                 </a:solidFill>
               </a:rPr>
-              <a:t> ara sertifika olmadan neden başarısız?</a:t>
+              <a:t> fail without the intermediate certificate?</a:t>
             </a:r>
           </a:p>
           <a:p>
@@ -12551,7 +12567,7 @@
                   <a:srgbClr val="1F2D3A"/>
                 </a:solidFill>
               </a:rPr>
-              <a:t>OCSP'ye ulaşamayınca kabul: hangi örüntü?</a:t>
+              <a:t>Accepting when OCSP is unreachable: which pattern?</a:t>
             </a:r>
           </a:p>
           <a:p>
@@ -12574,7 +12590,7 @@
                   <a:srgbClr val="1F2D3A"/>
                 </a:solidFill>
               </a:rPr>
-              <a:t>Kimliksiz DH'ye karşı ne yapılır?</a:t>
+              <a:t>What protects against unauthenticated DH?</a:t>
             </a:r>
           </a:p>
         </p:txBody>
@@ -12649,7 +12665,7 @@
                   <a:srgbClr val="5B6770"/>
                 </a:solidFill>
               </a:rPr>
-              <a:t>CEN429 Güvenli Programlama · Hafta 16</a:t>
+              <a:t>CEN429 Secure Programming · Week 16</a:t>
             </a:r>
           </a:p>
         </p:txBody>
@@ -12682,7 +12698,7 @@
                   <a:srgbClr val="5B6770"/>
                 </a:solidFill>
               </a:rPr>
-              <a:t>RTEÜ Bilgisayar Mühendisliği · 2026-2027 Güz</a:t>
+              <a:t>RTEU Computer Engineering · 2026-2027 Fall</a:t>
             </a:r>
           </a:p>
         </p:txBody>
@@ -12749,7 +12765,7 @@
                   <a:srgbClr val="006D77"/>
                 </a:solidFill>
               </a:rPr>
-              <a:t>Örnek sorular (12–13. haftalar)</a:t>
+              <a:t>Sample Questions (Weeks 12–13)</a:t>
             </a:r>
           </a:p>
         </p:txBody>
@@ -12795,7 +12811,7 @@
                   <a:srgbClr val="1F2D3A"/>
                 </a:solidFill>
               </a:rPr>
-              <a:t>TOE neden benzersiz tanımlanır?</a:t>
+              <a:t>Why must the TOE be uniquely defined?</a:t>
             </a:r>
           </a:p>
           <a:p>
@@ -12818,7 +12834,7 @@
                   <a:srgbClr val="1F2D3A"/>
                 </a:solidFill>
               </a:rPr>
-              <a:t>Etki analizi ile delta değerlendirme ilişkisi?</a:t>
+              <a:t>Relationship between impact analysis and delta assessment?</a:t>
             </a:r>
           </a:p>
           <a:p>
@@ -12841,7 +12857,7 @@
                   <a:srgbClr val="1F2D3A"/>
                 </a:solidFill>
               </a:rPr>
-              <a:t>"Uygulama güvenli olmalıdır" nasıl düzeltilir?</a:t>
+              <a:t>How is "the application must be secure" fixed?</a:t>
             </a:r>
           </a:p>
           <a:p>
@@ -12864,7 +12880,7 @@
                   <a:srgbClr val="1F2D3A"/>
                 </a:solidFill>
               </a:rPr>
-              <a:t>Kanıtsız "karşılandı" ne anlama gelir?</a:t>
+              <a:t>What does "met" without evidence mean?</a:t>
             </a:r>
           </a:p>
           <a:p>
@@ -12887,7 +12903,7 @@
                   <a:srgbClr val="1F2D3A"/>
                 </a:solidFill>
               </a:rPr>
-              <a:t>Kütüphane güvenli güncellemeyi karşılayamıyorsa?</a:t>
+              <a:t>If a library cannot meet the secure-update requirement?</a:t>
             </a:r>
           </a:p>
           <a:p>
@@ -12910,7 +12926,7 @@
                   <a:srgbClr val="1F2D3A"/>
                 </a:solidFill>
               </a:rPr>
-              <a:t>EAL4+ her zaman EAL2'den güvenli mi?</a:t>
+              <a:t>Is EAL4+ always more secure than EAL2?</a:t>
             </a:r>
           </a:p>
           <a:p>
@@ -12933,7 +12949,7 @@
                   <a:srgbClr val="1F2D3A"/>
                 </a:solidFill>
               </a:rPr>
-              <a:t>FIPS doğrulanmış kütüphane = uygulama FIPS uyumlu mu?</a:t>
+              <a:t>Does a FIPS-validated library mean the application is FIPS compliant?</a:t>
             </a:r>
           </a:p>
         </p:txBody>

</xml_diff>